<commit_message>
v1.12: Presentación comercial (barra azul, logo transparente, paginado, interlineados)
Made-with: Cursor
</commit_message>
<xml_diff>
--- a/presentacion/Propuesta_Pandi.pptx
+++ b/presentacion/Propuesta_Pandi.pptx
@@ -3110,7 +3110,7 @@
             <a:avLst/>
           </a:prstGeom>
           <a:solidFill>
-            <a:srgbClr val="0D7D3D"/>
+            <a:srgbClr val="0D2137"/>
           </a:solidFill>
           <a:ln>
             <a:noFill/>
@@ -3205,8 +3205,8 @@
         </p:nvSpPr>
         <p:spPr>
           <a:xfrm>
-            <a:off x="457200" y="868680"/>
-            <a:ext cx="11247120" cy="822960"/>
+            <a:off x="457200" y="914400"/>
+            <a:ext cx="11247120" cy="914400"/>
           </a:xfrm>
           <a:prstGeom prst="rect">
             <a:avLst/>
@@ -3220,6 +3220,9 @@
           <a:lstStyle/>
           <a:p>
             <a:pPr algn="ctr">
+              <a:lnSpc>
+                <a:spcPct val="120000"/>
+              </a:lnSpc>
               <a:defRPr sz="1800">
                 <a:solidFill>
                   <a:srgbClr val="555555"/>
@@ -3240,8 +3243,8 @@
         </p:nvSpPr>
         <p:spPr>
           <a:xfrm>
-            <a:off x="457200" y="6217920"/>
-            <a:ext cx="11247120" cy="365760"/>
+            <a:off x="457200" y="6263640"/>
+            <a:ext cx="11247120" cy="411480"/>
           </a:xfrm>
           <a:prstGeom prst="rect">
             <a:avLst/>
@@ -3263,6 +3266,41 @@
             </a:pPr>
             <a:r>
               <a:t>Confidencial · 10/03/2026</a:t>
+            </a:r>
+          </a:p>
+        </p:txBody>
+      </p:sp>
+      <p:sp>
+        <p:nvSpPr>
+          <p:cNvPr id="7" name="TextBox 6"/>
+          <p:cNvSpPr txBox="1"/>
+          <p:nvPr/>
+        </p:nvSpPr>
+        <p:spPr>
+          <a:xfrm>
+            <a:off x="10972800" y="6446520"/>
+            <a:ext cx="1097280" cy="320040"/>
+          </a:xfrm>
+          <a:prstGeom prst="rect">
+            <a:avLst/>
+          </a:prstGeom>
+          <a:noFill/>
+        </p:spPr>
+        <p:txBody>
+          <a:bodyPr wrap="none">
+            <a:spAutoFit/>
+          </a:bodyPr>
+          <a:lstStyle/>
+          <a:p>
+            <a:pPr algn="r">
+              <a:defRPr sz="1000">
+                <a:solidFill>
+                  <a:srgbClr val="555555"/>
+                </a:solidFill>
+              </a:defRPr>
+            </a:pPr>
+            <a:r>
+              <a:t>1 / 8</a:t>
             </a:r>
           </a:p>
         </p:txBody>
@@ -3300,7 +3338,7 @@
             <a:avLst/>
           </a:prstGeom>
           <a:solidFill>
-            <a:srgbClr val="0D7D3D"/>
+            <a:srgbClr val="0D2137"/>
           </a:solidFill>
           <a:ln>
             <a:noFill/>
@@ -3395,7 +3433,7 @@
         </p:nvSpPr>
         <p:spPr>
           <a:xfrm>
-            <a:off x="457200" y="868680"/>
+            <a:off x="457200" y="914400"/>
             <a:ext cx="11247120" cy="5486400"/>
           </a:xfrm>
           <a:prstGeom prst="rect">
@@ -3410,9 +3448,15 @@
           <a:lstStyle/>
           <a:p>
             <a:pPr>
+              <a:lnSpc>
+                <a:spcPct val="120000"/>
+              </a:lnSpc>
               <a:spcBef>
-                <a:spcPts val="600"/>
+                <a:spcPts val="800"/>
               </a:spcBef>
+              <a:spcAft>
+                <a:spcPts val="200"/>
+              </a:spcAft>
               <a:defRPr sz="1400">
                 <a:solidFill>
                   <a:srgbClr val="1A1A1A"/>
@@ -3425,9 +3469,15 @@
           </a:p>
           <a:p>
             <a:pPr>
+              <a:lnSpc>
+                <a:spcPct val="120000"/>
+              </a:lnSpc>
               <a:spcBef>
-                <a:spcPts val="600"/>
+                <a:spcPts val="800"/>
               </a:spcBef>
+              <a:spcAft>
+                <a:spcPts val="200"/>
+              </a:spcAft>
               <a:defRPr sz="1400">
                 <a:solidFill>
                   <a:srgbClr val="1A1A1A"/>
@@ -3440,9 +3490,15 @@
           </a:p>
           <a:p>
             <a:pPr>
+              <a:lnSpc>
+                <a:spcPct val="120000"/>
+              </a:lnSpc>
               <a:spcBef>
-                <a:spcPts val="600"/>
+                <a:spcPts val="800"/>
               </a:spcBef>
+              <a:spcAft>
+                <a:spcPts val="200"/>
+              </a:spcAft>
               <a:defRPr sz="1400">
                 <a:solidFill>
                   <a:srgbClr val="1A1A1A"/>
@@ -3455,9 +3511,15 @@
           </a:p>
           <a:p>
             <a:pPr>
+              <a:lnSpc>
+                <a:spcPct val="120000"/>
+              </a:lnSpc>
               <a:spcBef>
-                <a:spcPts val="600"/>
+                <a:spcPts val="800"/>
               </a:spcBef>
+              <a:spcAft>
+                <a:spcPts val="200"/>
+              </a:spcAft>
               <a:defRPr sz="1400">
                 <a:solidFill>
                   <a:srgbClr val="1A1A1A"/>
@@ -3470,6 +3532,9 @@
           </a:p>
           <a:p>
             <a:pPr>
+              <a:lnSpc>
+                <a:spcPct val="120000"/>
+              </a:lnSpc>
               <a:defRPr sz="1400">
                 <a:solidFill>
                   <a:srgbClr val="1A1A1A"/>
@@ -3479,9 +3544,15 @@
           </a:p>
           <a:p>
             <a:pPr>
+              <a:lnSpc>
+                <a:spcPct val="120000"/>
+              </a:lnSpc>
               <a:spcBef>
-                <a:spcPts val="600"/>
+                <a:spcPts val="800"/>
               </a:spcBef>
+              <a:spcAft>
+                <a:spcPts val="200"/>
+              </a:spcAft>
               <a:defRPr sz="1400">
                 <a:solidFill>
                   <a:srgbClr val="1A1A1A"/>
@@ -3490,6 +3561,41 @@
             </a:pPr>
             <a:r>
               <a:t>• Centralizar la operación, con seguridad y sin perder el control.</a:t>
+            </a:r>
+          </a:p>
+        </p:txBody>
+      </p:sp>
+      <p:sp>
+        <p:nvSpPr>
+          <p:cNvPr id="6" name="TextBox 5"/>
+          <p:cNvSpPr txBox="1"/>
+          <p:nvPr/>
+        </p:nvSpPr>
+        <p:spPr>
+          <a:xfrm>
+            <a:off x="10972800" y="6446520"/>
+            <a:ext cx="1097280" cy="320040"/>
+          </a:xfrm>
+          <a:prstGeom prst="rect">
+            <a:avLst/>
+          </a:prstGeom>
+          <a:noFill/>
+        </p:spPr>
+        <p:txBody>
+          <a:bodyPr wrap="none">
+            <a:spAutoFit/>
+          </a:bodyPr>
+          <a:lstStyle/>
+          <a:p>
+            <a:pPr algn="r">
+              <a:defRPr sz="1000">
+                <a:solidFill>
+                  <a:srgbClr val="555555"/>
+                </a:solidFill>
+              </a:defRPr>
+            </a:pPr>
+            <a:r>
+              <a:t>2 / 8</a:t>
             </a:r>
           </a:p>
         </p:txBody>
@@ -3527,7 +3633,7 @@
             <a:avLst/>
           </a:prstGeom>
           <a:solidFill>
-            <a:srgbClr val="0D7D3D"/>
+            <a:srgbClr val="0D2137"/>
           </a:solidFill>
           <a:ln>
             <a:noFill/>
@@ -3622,7 +3728,7 @@
         </p:nvSpPr>
         <p:spPr>
           <a:xfrm>
-            <a:off x="457200" y="868680"/>
+            <a:off x="457200" y="914400"/>
             <a:ext cx="11247120" cy="5486400"/>
           </a:xfrm>
           <a:prstGeom prst="rect">
@@ -3637,9 +3743,15 @@
           <a:lstStyle/>
           <a:p>
             <a:pPr>
+              <a:lnSpc>
+                <a:spcPct val="120000"/>
+              </a:lnSpc>
               <a:spcBef>
-                <a:spcPts val="600"/>
+                <a:spcPts val="800"/>
               </a:spcBef>
+              <a:spcAft>
+                <a:spcPts val="200"/>
+              </a:spcAft>
               <a:defRPr sz="1400">
                 <a:solidFill>
                   <a:srgbClr val="1A1A1A"/>
@@ -3652,9 +3764,15 @@
           </a:p>
           <a:p>
             <a:pPr>
+              <a:lnSpc>
+                <a:spcPct val="120000"/>
+              </a:lnSpc>
               <a:spcBef>
-                <a:spcPts val="600"/>
+                <a:spcPts val="800"/>
               </a:spcBef>
+              <a:spcAft>
+                <a:spcPts val="200"/>
+              </a:spcAft>
               <a:defRPr sz="1400">
                 <a:solidFill>
                   <a:srgbClr val="1A1A1A"/>
@@ -3667,9 +3785,15 @@
           </a:p>
           <a:p>
             <a:pPr>
+              <a:lnSpc>
+                <a:spcPct val="120000"/>
+              </a:lnSpc>
               <a:spcBef>
-                <a:spcPts val="600"/>
+                <a:spcPts val="800"/>
               </a:spcBef>
+              <a:spcAft>
+                <a:spcPts val="200"/>
+              </a:spcAft>
               <a:defRPr sz="1400">
                 <a:solidFill>
                   <a:srgbClr val="1A1A1A"/>
@@ -3682,9 +3806,15 @@
           </a:p>
           <a:p>
             <a:pPr>
+              <a:lnSpc>
+                <a:spcPct val="120000"/>
+              </a:lnSpc>
               <a:spcBef>
-                <a:spcPts val="600"/>
+                <a:spcPts val="800"/>
               </a:spcBef>
+              <a:spcAft>
+                <a:spcPts val="200"/>
+              </a:spcAft>
               <a:defRPr sz="1400">
                 <a:solidFill>
                   <a:srgbClr val="1A1A1A"/>
@@ -3697,9 +3827,15 @@
           </a:p>
           <a:p>
             <a:pPr>
+              <a:lnSpc>
+                <a:spcPct val="120000"/>
+              </a:lnSpc>
               <a:spcBef>
-                <a:spcPts val="600"/>
+                <a:spcPts val="800"/>
               </a:spcBef>
+              <a:spcAft>
+                <a:spcPts val="200"/>
+              </a:spcAft>
               <a:defRPr sz="1400">
                 <a:solidFill>
                   <a:srgbClr val="1A1A1A"/>
@@ -3712,9 +3848,15 @@
           </a:p>
           <a:p>
             <a:pPr>
+              <a:lnSpc>
+                <a:spcPct val="120000"/>
+              </a:lnSpc>
               <a:spcBef>
-                <a:spcPts val="600"/>
+                <a:spcPts val="800"/>
               </a:spcBef>
+              <a:spcAft>
+                <a:spcPts val="200"/>
+              </a:spcAft>
               <a:defRPr sz="1400">
                 <a:solidFill>
                   <a:srgbClr val="1A1A1A"/>
@@ -3727,6 +3869,9 @@
           </a:p>
           <a:p>
             <a:pPr>
+              <a:lnSpc>
+                <a:spcPct val="120000"/>
+              </a:lnSpc>
               <a:defRPr sz="1400">
                 <a:solidFill>
                   <a:srgbClr val="1A1A1A"/>
@@ -3736,9 +3881,15 @@
           </a:p>
           <a:p>
             <a:pPr>
+              <a:lnSpc>
+                <a:spcPct val="120000"/>
+              </a:lnSpc>
               <a:spcBef>
-                <a:spcPts val="600"/>
+                <a:spcPts val="800"/>
               </a:spcBef>
+              <a:spcAft>
+                <a:spcPts val="200"/>
+              </a:spcAft>
               <a:defRPr sz="1400">
                 <a:solidFill>
                   <a:srgbClr val="1A1A1A"/>
@@ -3747,6 +3898,41 @@
             </a:pPr>
             <a:r>
               <a:t>• Todo en un solo sistema, accesible desde el navegador.</a:t>
+            </a:r>
+          </a:p>
+        </p:txBody>
+      </p:sp>
+      <p:sp>
+        <p:nvSpPr>
+          <p:cNvPr id="6" name="TextBox 5"/>
+          <p:cNvSpPr txBox="1"/>
+          <p:nvPr/>
+        </p:nvSpPr>
+        <p:spPr>
+          <a:xfrm>
+            <a:off x="10972800" y="6446520"/>
+            <a:ext cx="1097280" cy="320040"/>
+          </a:xfrm>
+          <a:prstGeom prst="rect">
+            <a:avLst/>
+          </a:prstGeom>
+          <a:noFill/>
+        </p:spPr>
+        <p:txBody>
+          <a:bodyPr wrap="none">
+            <a:spAutoFit/>
+          </a:bodyPr>
+          <a:lstStyle/>
+          <a:p>
+            <a:pPr algn="r">
+              <a:defRPr sz="1000">
+                <a:solidFill>
+                  <a:srgbClr val="555555"/>
+                </a:solidFill>
+              </a:defRPr>
+            </a:pPr>
+            <a:r>
+              <a:t>3 / 8</a:t>
             </a:r>
           </a:p>
         </p:txBody>
@@ -3784,7 +3970,7 @@
             <a:avLst/>
           </a:prstGeom>
           <a:solidFill>
-            <a:srgbClr val="0D7D3D"/>
+            <a:srgbClr val="0D2137"/>
           </a:solidFill>
           <a:ln>
             <a:noFill/>
@@ -3880,8 +4066,8 @@
           <p:nvPr/>
         </p:nvGraphicFramePr>
         <p:xfrm>
-          <a:off x="457200" y="868680"/>
-          <a:ext cx="11247120" cy="2880360"/>
+          <a:off x="457200" y="914400"/>
+          <a:ext cx="11247120" cy="2852928"/>
         </p:xfrm>
         <a:graphic>
           <a:graphicData uri="http://schemas.openxmlformats.org/drawingml/2006/table">
@@ -3893,14 +4079,14 @@
                 <a:gridCol w="5623560"/>
                 <a:gridCol w="5623560"/>
               </a:tblGrid>
-              <a:tr h="480060">
+              <a:tr h="475488">
                 <a:tc>
                   <a:txBody>
                     <a:bodyPr/>
                     <a:lstStyle/>
                     <a:p>
                       <a:pPr>
-                        <a:defRPr b="1">
+                        <a:defRPr b="1" sz="1200">
                           <a:solidFill>
                             <a:srgbClr val="FFFFFF"/>
                           </a:solidFill>
@@ -3913,7 +4099,7 @@
                   </a:txBody>
                   <a:tcPr>
                     <a:solidFill>
-                      <a:srgbClr val="0D7D3D"/>
+                      <a:srgbClr val="0D2137"/>
                     </a:solidFill>
                   </a:tcPr>
                 </a:tc>
@@ -3923,7 +4109,7 @@
                     <a:lstStyle/>
                     <a:p>
                       <a:pPr>
-                        <a:defRPr b="1">
+                        <a:defRPr b="1" sz="1200">
                           <a:solidFill>
                             <a:srgbClr val="FFFFFF"/>
                           </a:solidFill>
@@ -3936,17 +4122,29 @@
                   </a:txBody>
                   <a:tcPr>
                     <a:solidFill>
-                      <a:srgbClr val="0D7D3D"/>
+                      <a:srgbClr val="0D2137"/>
                     </a:solidFill>
                   </a:tcPr>
                 </a:tc>
               </a:tr>
-              <a:tr h="480060">
+              <a:tr h="475488">
                 <a:tc>
                   <a:txBody>
                     <a:bodyPr/>
                     <a:lstStyle/>
                     <a:p>
+                      <a:pPr>
+                        <a:lnSpc>
+                          <a:spcPct val="120000"/>
+                        </a:lnSpc>
+                        <a:spcBef>
+                          <a:spcPts val="400"/>
+                        </a:spcBef>
+                        <a:spcAft>
+                          <a:spcPts val="400"/>
+                        </a:spcAft>
+                        <a:defRPr sz="1200"/>
+                      </a:pPr>
                       <a:r>
                         <a:t>Trazabilidad</a:t>
                       </a:r>
@@ -3959,6 +4157,18 @@
                     <a:bodyPr/>
                     <a:lstStyle/>
                     <a:p>
+                      <a:pPr>
+                        <a:lnSpc>
+                          <a:spcPct val="120000"/>
+                        </a:lnSpc>
+                        <a:spcBef>
+                          <a:spcPts val="400"/>
+                        </a:spcBef>
+                        <a:spcAft>
+                          <a:spcPts val="400"/>
+                        </a:spcAft>
+                        <a:defRPr sz="1200"/>
+                      </a:pPr>
                       <a:r>
                         <a:t>Cada orden y transacción registrada y vinculada a caja y cuenta corriente.</a:t>
                       </a:r>
@@ -3967,12 +4177,24 @@
                   <a:tcPr/>
                 </a:tc>
               </a:tr>
-              <a:tr h="480060">
+              <a:tr h="475488">
                 <a:tc>
                   <a:txBody>
                     <a:bodyPr/>
                     <a:lstStyle/>
                     <a:p>
+                      <a:pPr>
+                        <a:lnSpc>
+                          <a:spcPct val="120000"/>
+                        </a:lnSpc>
+                        <a:spcBef>
+                          <a:spcPts val="400"/>
+                        </a:spcBef>
+                        <a:spcAft>
+                          <a:spcPts val="400"/>
+                        </a:spcAft>
+                        <a:defRPr sz="1200"/>
+                      </a:pPr>
                       <a:r>
                         <a:t>Control por roles</a:t>
                       </a:r>
@@ -3985,6 +4207,18 @@
                     <a:bodyPr/>
                     <a:lstStyle/>
                     <a:p>
+                      <a:pPr>
+                        <a:lnSpc>
+                          <a:spcPct val="120000"/>
+                        </a:lnSpc>
+                        <a:spcBef>
+                          <a:spcPts val="400"/>
+                        </a:spcBef>
+                        <a:spcAft>
+                          <a:spcPts val="400"/>
+                        </a:spcAft>
+                        <a:defRPr sz="1200"/>
+                      </a:pPr>
                       <a:r>
                         <a:t>Admin, encargado y visor ven solo lo que necesitan; permisos por vista y por acción.</a:t>
                       </a:r>
@@ -3993,12 +4227,24 @@
                   <a:tcPr/>
                 </a:tc>
               </a:tr>
-              <a:tr h="480060">
+              <a:tr h="475488">
                 <a:tc>
                   <a:txBody>
                     <a:bodyPr/>
                     <a:lstStyle/>
                     <a:p>
+                      <a:pPr>
+                        <a:lnSpc>
+                          <a:spcPct val="120000"/>
+                        </a:lnSpc>
+                        <a:spcBef>
+                          <a:spcPts val="400"/>
+                        </a:spcBef>
+                        <a:spcAft>
+                          <a:spcPts val="400"/>
+                        </a:spcAft>
+                        <a:defRPr sz="1200"/>
+                      </a:pPr>
                       <a:r>
                         <a:t>Menos errores</a:t>
                       </a:r>
@@ -4011,6 +4257,18 @@
                     <a:bodyPr/>
                     <a:lstStyle/>
                     <a:p>
+                      <a:pPr>
+                        <a:lnSpc>
+                          <a:spcPct val="120000"/>
+                        </a:lnSpc>
+                        <a:spcBef>
+                          <a:spcPts val="400"/>
+                        </a:spcBef>
+                        <a:spcAft>
+                          <a:spcPts val="400"/>
+                        </a:spcAft>
+                        <a:defRPr sz="1200"/>
+                      </a:pPr>
                       <a:r>
                         <a:t>Concertación única, validaciones y mensajería clara.</a:t>
                       </a:r>
@@ -4019,12 +4277,24 @@
                   <a:tcPr/>
                 </a:tc>
               </a:tr>
-              <a:tr h="480060">
+              <a:tr h="475488">
                 <a:tc>
                   <a:txBody>
                     <a:bodyPr/>
                     <a:lstStyle/>
                     <a:p>
+                      <a:pPr>
+                        <a:lnSpc>
+                          <a:spcPct val="120000"/>
+                        </a:lnSpc>
+                        <a:spcBef>
+                          <a:spcPts val="400"/>
+                        </a:spcBef>
+                        <a:spcAft>
+                          <a:spcPts val="400"/>
+                        </a:spcAft>
+                        <a:defRPr sz="1200"/>
+                      </a:pPr>
                       <a:r>
                         <a:t>Múltiples monedas</a:t>
                       </a:r>
@@ -4037,6 +4307,18 @@
                     <a:bodyPr/>
                     <a:lstStyle/>
                     <a:p>
+                      <a:pPr>
+                        <a:lnSpc>
+                          <a:spcPct val="120000"/>
+                        </a:lnSpc>
+                        <a:spcBef>
+                          <a:spcPts val="400"/>
+                        </a:spcBef>
+                        <a:spcAft>
+                          <a:spcPts val="400"/>
+                        </a:spcAft>
+                        <a:defRPr sz="1200"/>
+                      </a:pPr>
                       <a:r>
                         <a:t>USD, EUR, ARS en cajas y cuenta corriente; tipos de operación configurables.</a:t>
                       </a:r>
@@ -4045,12 +4327,24 @@
                   <a:tcPr/>
                 </a:tc>
               </a:tr>
-              <a:tr h="480060">
+              <a:tr h="475488">
                 <a:tc>
                   <a:txBody>
                     <a:bodyPr/>
                     <a:lstStyle/>
                     <a:p>
+                      <a:pPr>
+                        <a:lnSpc>
+                          <a:spcPct val="120000"/>
+                        </a:lnSpc>
+                        <a:spcBef>
+                          <a:spcPts val="400"/>
+                        </a:spcBef>
+                        <a:spcAft>
+                          <a:spcPts val="400"/>
+                        </a:spcAft>
+                        <a:defRPr sz="1200"/>
+                      </a:pPr>
                       <a:r>
                         <a:t>Uso en celular</a:t>
                       </a:r>
@@ -4063,6 +4357,18 @@
                     <a:bodyPr/>
                     <a:lstStyle/>
                     <a:p>
+                      <a:pPr>
+                        <a:lnSpc>
+                          <a:spcPct val="120000"/>
+                        </a:lnSpc>
+                        <a:spcBef>
+                          <a:spcPts val="400"/>
+                        </a:spcBef>
+                        <a:spcAft>
+                          <a:spcPts val="400"/>
+                        </a:spcAft>
+                        <a:defRPr sz="1200"/>
+                      </a:pPr>
                       <a:r>
                         <a:t>Interfaz adaptable para consultas y tareas básicas en movimiento.</a:t>
                       </a:r>
@@ -4075,6 +4381,41 @@
           </a:graphicData>
         </a:graphic>
       </p:graphicFrame>
+      <p:sp>
+        <p:nvSpPr>
+          <p:cNvPr id="6" name="TextBox 5"/>
+          <p:cNvSpPr txBox="1"/>
+          <p:nvPr/>
+        </p:nvSpPr>
+        <p:spPr>
+          <a:xfrm>
+            <a:off x="10972800" y="6446520"/>
+            <a:ext cx="1097280" cy="320040"/>
+          </a:xfrm>
+          <a:prstGeom prst="rect">
+            <a:avLst/>
+          </a:prstGeom>
+          <a:noFill/>
+        </p:spPr>
+        <p:txBody>
+          <a:bodyPr wrap="none">
+            <a:spAutoFit/>
+          </a:bodyPr>
+          <a:lstStyle/>
+          <a:p>
+            <a:pPr algn="r">
+              <a:defRPr sz="1000">
+                <a:solidFill>
+                  <a:srgbClr val="555555"/>
+                </a:solidFill>
+              </a:defRPr>
+            </a:pPr>
+            <a:r>
+              <a:t>4 / 8</a:t>
+            </a:r>
+          </a:p>
+        </p:txBody>
+      </p:sp>
     </p:spTree>
   </p:cSld>
   <p:clrMapOvr>
@@ -4108,7 +4449,7 @@
             <a:avLst/>
           </a:prstGeom>
           <a:solidFill>
-            <a:srgbClr val="0D7D3D"/>
+            <a:srgbClr val="0D2137"/>
           </a:solidFill>
           <a:ln>
             <a:noFill/>
@@ -4203,8 +4544,8 @@
         </p:nvSpPr>
         <p:spPr>
           <a:xfrm>
-            <a:off x="457200" y="868680"/>
-            <a:ext cx="11247120" cy="5394960"/>
+            <a:off x="457200" y="914400"/>
+            <a:ext cx="11247120" cy="5349240"/>
           </a:xfrm>
           <a:prstGeom prst="rect">
             <a:avLst/>
@@ -4218,9 +4559,15 @@
           <a:lstStyle/>
           <a:p>
             <a:pPr>
+              <a:lnSpc>
+                <a:spcPct val="120000"/>
+              </a:lnSpc>
               <a:spcBef>
-                <a:spcPts val="300"/>
+                <a:spcPts val="500"/>
               </a:spcBef>
+              <a:spcAft>
+                <a:spcPts val="200"/>
+              </a:spcAft>
               <a:defRPr sz="1200">
                 <a:solidFill>
                   <a:srgbClr val="1A1A1A"/>
@@ -4233,9 +4580,15 @@
           </a:p>
           <a:p>
             <a:pPr>
+              <a:lnSpc>
+                <a:spcPct val="120000"/>
+              </a:lnSpc>
               <a:spcBef>
-                <a:spcPts val="300"/>
+                <a:spcPts val="500"/>
               </a:spcBef>
+              <a:spcAft>
+                <a:spcPts val="200"/>
+              </a:spcAft>
               <a:defRPr sz="1200">
                 <a:solidFill>
                   <a:srgbClr val="1A1A1A"/>
@@ -4248,9 +4601,15 @@
           </a:p>
           <a:p>
             <a:pPr>
+              <a:lnSpc>
+                <a:spcPct val="120000"/>
+              </a:lnSpc>
               <a:spcBef>
-                <a:spcPts val="300"/>
+                <a:spcPts val="500"/>
               </a:spcBef>
+              <a:spcAft>
+                <a:spcPts val="200"/>
+              </a:spcAft>
               <a:defRPr sz="1200">
                 <a:solidFill>
                   <a:srgbClr val="1A1A1A"/>
@@ -4263,9 +4622,15 @@
           </a:p>
           <a:p>
             <a:pPr>
+              <a:lnSpc>
+                <a:spcPct val="120000"/>
+              </a:lnSpc>
               <a:spcBef>
-                <a:spcPts val="300"/>
+                <a:spcPts val="500"/>
               </a:spcBef>
+              <a:spcAft>
+                <a:spcPts val="200"/>
+              </a:spcAft>
               <a:defRPr sz="1200">
                 <a:solidFill>
                   <a:srgbClr val="1A1A1A"/>
@@ -4278,9 +4643,15 @@
           </a:p>
           <a:p>
             <a:pPr>
+              <a:lnSpc>
+                <a:spcPct val="120000"/>
+              </a:lnSpc>
               <a:spcBef>
-                <a:spcPts val="300"/>
+                <a:spcPts val="500"/>
               </a:spcBef>
+              <a:spcAft>
+                <a:spcPts val="200"/>
+              </a:spcAft>
               <a:defRPr sz="1200">
                 <a:solidFill>
                   <a:srgbClr val="1A1A1A"/>
@@ -4293,9 +4664,15 @@
           </a:p>
           <a:p>
             <a:pPr>
+              <a:lnSpc>
+                <a:spcPct val="120000"/>
+              </a:lnSpc>
               <a:spcBef>
-                <a:spcPts val="300"/>
+                <a:spcPts val="500"/>
               </a:spcBef>
+              <a:spcAft>
+                <a:spcPts val="200"/>
+              </a:spcAft>
               <a:defRPr sz="1200">
                 <a:solidFill>
                   <a:srgbClr val="1A1A1A"/>
@@ -4308,9 +4685,15 @@
           </a:p>
           <a:p>
             <a:pPr>
+              <a:lnSpc>
+                <a:spcPct val="120000"/>
+              </a:lnSpc>
               <a:spcBef>
-                <a:spcPts val="300"/>
+                <a:spcPts val="500"/>
               </a:spcBef>
+              <a:spcAft>
+                <a:spcPts val="200"/>
+              </a:spcAft>
               <a:defRPr sz="1200">
                 <a:solidFill>
                   <a:srgbClr val="1A1A1A"/>
@@ -4323,9 +4706,15 @@
           </a:p>
           <a:p>
             <a:pPr>
+              <a:lnSpc>
+                <a:spcPct val="120000"/>
+              </a:lnSpc>
               <a:spcBef>
-                <a:spcPts val="300"/>
+                <a:spcPts val="500"/>
               </a:spcBef>
+              <a:spcAft>
+                <a:spcPts val="200"/>
+              </a:spcAft>
               <a:defRPr sz="1200">
                 <a:solidFill>
                   <a:srgbClr val="1A1A1A"/>
@@ -4338,9 +4727,15 @@
           </a:p>
           <a:p>
             <a:pPr>
+              <a:lnSpc>
+                <a:spcPct val="120000"/>
+              </a:lnSpc>
               <a:spcBef>
-                <a:spcPts val="300"/>
+                <a:spcPts val="500"/>
               </a:spcBef>
+              <a:spcAft>
+                <a:spcPts val="200"/>
+              </a:spcAft>
               <a:defRPr sz="1200">
                 <a:solidFill>
                   <a:srgbClr val="1A1A1A"/>
@@ -4353,9 +4748,15 @@
           </a:p>
           <a:p>
             <a:pPr>
+              <a:lnSpc>
+                <a:spcPct val="120000"/>
+              </a:lnSpc>
               <a:spcBef>
-                <a:spcPts val="300"/>
+                <a:spcPts val="500"/>
               </a:spcBef>
+              <a:spcAft>
+                <a:spcPts val="200"/>
+              </a:spcAft>
               <a:defRPr sz="1200">
                 <a:solidFill>
                   <a:srgbClr val="1A1A1A"/>
@@ -4368,9 +4769,15 @@
           </a:p>
           <a:p>
             <a:pPr>
+              <a:lnSpc>
+                <a:spcPct val="120000"/>
+              </a:lnSpc>
               <a:spcBef>
-                <a:spcPts val="300"/>
+                <a:spcPts val="500"/>
               </a:spcBef>
+              <a:spcAft>
+                <a:spcPts val="200"/>
+              </a:spcAft>
               <a:defRPr sz="1200">
                 <a:solidFill>
                   <a:srgbClr val="1A1A1A"/>
@@ -4383,9 +4790,15 @@
           </a:p>
           <a:p>
             <a:pPr>
+              <a:lnSpc>
+                <a:spcPct val="120000"/>
+              </a:lnSpc>
               <a:spcBef>
-                <a:spcPts val="300"/>
+                <a:spcPts val="500"/>
               </a:spcBef>
+              <a:spcAft>
+                <a:spcPts val="200"/>
+              </a:spcAft>
               <a:defRPr sz="1200">
                 <a:solidFill>
                   <a:srgbClr val="1A1A1A"/>
@@ -4398,9 +4811,15 @@
           </a:p>
           <a:p>
             <a:pPr>
+              <a:lnSpc>
+                <a:spcPct val="120000"/>
+              </a:lnSpc>
               <a:spcBef>
-                <a:spcPts val="300"/>
+                <a:spcPts val="500"/>
               </a:spcBef>
+              <a:spcAft>
+                <a:spcPts val="200"/>
+              </a:spcAft>
               <a:defRPr sz="1200">
                 <a:solidFill>
                   <a:srgbClr val="1A1A1A"/>
@@ -4409,6 +4828,41 @@
             </a:pPr>
             <a:r>
               <a:t>13. Documentación y despliegue continuo.</a:t>
+            </a:r>
+          </a:p>
+        </p:txBody>
+      </p:sp>
+      <p:sp>
+        <p:nvSpPr>
+          <p:cNvPr id="6" name="TextBox 5"/>
+          <p:cNvSpPr txBox="1"/>
+          <p:nvPr/>
+        </p:nvSpPr>
+        <p:spPr>
+          <a:xfrm>
+            <a:off x="10972800" y="6446520"/>
+            <a:ext cx="1097280" cy="320040"/>
+          </a:xfrm>
+          <a:prstGeom prst="rect">
+            <a:avLst/>
+          </a:prstGeom>
+          <a:noFill/>
+        </p:spPr>
+        <p:txBody>
+          <a:bodyPr wrap="none">
+            <a:spAutoFit/>
+          </a:bodyPr>
+          <a:lstStyle/>
+          <a:p>
+            <a:pPr algn="r">
+              <a:defRPr sz="1000">
+                <a:solidFill>
+                  <a:srgbClr val="555555"/>
+                </a:solidFill>
+              </a:defRPr>
+            </a:pPr>
+            <a:r>
+              <a:t>5 / 8</a:t>
             </a:r>
           </a:p>
         </p:txBody>
@@ -4446,7 +4900,7 @@
             <a:avLst/>
           </a:prstGeom>
           <a:solidFill>
-            <a:srgbClr val="0D7D3D"/>
+            <a:srgbClr val="0D2137"/>
           </a:solidFill>
           <a:ln>
             <a:noFill/>
@@ -4541,8 +4995,8 @@
         </p:nvSpPr>
         <p:spPr>
           <a:xfrm>
-            <a:off x="457200" y="749808"/>
-            <a:ext cx="11247120" cy="256032"/>
+            <a:off x="457200" y="804672"/>
+            <a:ext cx="11247120" cy="365760"/>
           </a:xfrm>
           <a:prstGeom prst="rect">
             <a:avLst/>
@@ -4556,6 +5010,9 @@
           <a:lstStyle/>
           <a:p>
             <a:pPr>
+              <a:lnSpc>
+                <a:spcPct val="100000"/>
+              </a:lnSpc>
               <a:defRPr sz="1000">
                 <a:solidFill>
                   <a:srgbClr val="555555"/>
@@ -4563,7 +5020,7 @@
               </a:defRPr>
             </a:pPr>
             <a:r>
-              <a:t>Tarifa de referencia: USD 38/h (Argentina). Datos: solapa Presupuesto de la bitácora.</a:t>
+              <a:t>Tarifa de referencia: USD 38/h (Argentina). Fuente: Bitácora del proyecto, solapa Presupuesto.</a:t>
             </a:r>
           </a:p>
         </p:txBody>
@@ -4577,8 +5034,8 @@
           <p:nvPr/>
         </p:nvGraphicFramePr>
         <p:xfrm>
-          <a:off x="457200" y="1051560"/>
-          <a:ext cx="11247120" cy="4114800"/>
+          <a:off x="457200" y="1207008"/>
+          <a:ext cx="11247120" cy="4754880"/>
         </p:xfrm>
         <a:graphic>
           <a:graphicData uri="http://schemas.openxmlformats.org/drawingml/2006/table">
@@ -4591,14 +5048,14 @@
                 <a:gridCol w="3749040"/>
                 <a:gridCol w="3749040"/>
               </a:tblGrid>
-              <a:tr h="274320">
+              <a:tr h="316992">
                 <a:tc>
                   <a:txBody>
                     <a:bodyPr/>
                     <a:lstStyle/>
                     <a:p>
                       <a:pPr>
-                        <a:defRPr b="1">
+                        <a:defRPr b="1" sz="1100">
                           <a:solidFill>
                             <a:srgbClr val="FFFFFF"/>
                           </a:solidFill>
@@ -4611,7 +5068,7 @@
                   </a:txBody>
                   <a:tcPr>
                     <a:solidFill>
-                      <a:srgbClr val="0D7D3D"/>
+                      <a:srgbClr val="0D2137"/>
                     </a:solidFill>
                   </a:tcPr>
                 </a:tc>
@@ -4621,7 +5078,7 @@
                     <a:lstStyle/>
                     <a:p>
                       <a:pPr algn="r">
-                        <a:defRPr b="1">
+                        <a:defRPr b="1" sz="1100">
                           <a:solidFill>
                             <a:srgbClr val="FFFFFF"/>
                           </a:solidFill>
@@ -4634,7 +5091,7 @@
                   </a:txBody>
                   <a:tcPr>
                     <a:solidFill>
-                      <a:srgbClr val="0D7D3D"/>
+                      <a:srgbClr val="0D2137"/>
                     </a:solidFill>
                   </a:tcPr>
                 </a:tc>
@@ -4644,7 +5101,7 @@
                     <a:lstStyle/>
                     <a:p>
                       <a:pPr algn="r">
-                        <a:defRPr b="1">
+                        <a:defRPr b="1" sz="1100">
                           <a:solidFill>
                             <a:srgbClr val="FFFFFF"/>
                           </a:solidFill>
@@ -4657,17 +5114,29 @@
                   </a:txBody>
                   <a:tcPr>
                     <a:solidFill>
-                      <a:srgbClr val="0D7D3D"/>
+                      <a:srgbClr val="0D2137"/>
                     </a:solidFill>
                   </a:tcPr>
                 </a:tc>
               </a:tr>
-              <a:tr h="274320">
+              <a:tr h="316992">
                 <a:tc>
                   <a:txBody>
                     <a:bodyPr/>
                     <a:lstStyle/>
                     <a:p>
+                      <a:pPr>
+                        <a:lnSpc>
+                          <a:spcPct val="120000"/>
+                        </a:lnSpc>
+                        <a:spcBef>
+                          <a:spcPts val="300"/>
+                        </a:spcBef>
+                        <a:spcAft>
+                          <a:spcPts val="300"/>
+                        </a:spcAft>
+                        <a:defRPr sz="1000"/>
+                      </a:pPr>
                       <a:r>
                         <a:t>Setup y arquitectura (repo Supabase Vercel config)</a:t>
                       </a:r>
@@ -4680,7 +5149,18 @@
                     <a:bodyPr/>
                     <a:lstStyle/>
                     <a:p>
-                      <a:pPr algn="r"/>
+                      <a:pPr algn="r">
+                        <a:lnSpc>
+                          <a:spcPct val="120000"/>
+                        </a:lnSpc>
+                        <a:spcBef>
+                          <a:spcPts val="300"/>
+                        </a:spcBef>
+                        <a:spcAft>
+                          <a:spcPts val="300"/>
+                        </a:spcAft>
+                        <a:defRPr sz="1000"/>
+                      </a:pPr>
                       <a:r>
                         <a:t>12</a:t>
                       </a:r>
@@ -4693,7 +5173,18 @@
                     <a:bodyPr/>
                     <a:lstStyle/>
                     <a:p>
-                      <a:pPr algn="r"/>
+                      <a:pPr algn="r">
+                        <a:lnSpc>
+                          <a:spcPct val="120000"/>
+                        </a:lnSpc>
+                        <a:spcBef>
+                          <a:spcPts val="300"/>
+                        </a:spcBef>
+                        <a:spcAft>
+                          <a:spcPts val="300"/>
+                        </a:spcAft>
+                        <a:defRPr sz="1000"/>
+                      </a:pPr>
                       <a:r>
                         <a:t>456</a:t>
                       </a:r>
@@ -4702,12 +5193,24 @@
                   <a:tcPr/>
                 </a:tc>
               </a:tr>
-              <a:tr h="274320">
+              <a:tr h="316992">
                 <a:tc>
                   <a:txBody>
                     <a:bodyPr/>
                     <a:lstStyle/>
                     <a:p>
+                      <a:pPr>
+                        <a:lnSpc>
+                          <a:spcPct val="120000"/>
+                        </a:lnSpc>
+                        <a:spcBef>
+                          <a:spcPts val="300"/>
+                        </a:spcBef>
+                        <a:spcAft>
+                          <a:spcPts val="300"/>
+                        </a:spcAft>
+                        <a:defRPr sz="1000"/>
+                      </a:pPr>
                       <a:r>
                         <a:t>Autenticación y seguridad (Auth roles permisos RLS)</a:t>
                       </a:r>
@@ -4720,7 +5223,18 @@
                     <a:bodyPr/>
                     <a:lstStyle/>
                     <a:p>
-                      <a:pPr algn="r"/>
+                      <a:pPr algn="r">
+                        <a:lnSpc>
+                          <a:spcPct val="120000"/>
+                        </a:lnSpc>
+                        <a:spcBef>
+                          <a:spcPts val="300"/>
+                        </a:spcBef>
+                        <a:spcAft>
+                          <a:spcPts val="300"/>
+                        </a:spcAft>
+                        <a:defRPr sz="1000"/>
+                      </a:pPr>
                       <a:r>
                         <a:t>24</a:t>
                       </a:r>
@@ -4733,7 +5247,18 @@
                     <a:bodyPr/>
                     <a:lstStyle/>
                     <a:p>
-                      <a:pPr algn="r"/>
+                      <a:pPr algn="r">
+                        <a:lnSpc>
+                          <a:spcPct val="120000"/>
+                        </a:lnSpc>
+                        <a:spcBef>
+                          <a:spcPts val="300"/>
+                        </a:spcBef>
+                        <a:spcAft>
+                          <a:spcPts val="300"/>
+                        </a:spcAft>
+                        <a:defRPr sz="1000"/>
+                      </a:pPr>
                       <a:r>
                         <a:t>912</a:t>
                       </a:r>
@@ -4742,12 +5267,24 @@
                   <a:tcPr/>
                 </a:tc>
               </a:tr>
-              <a:tr h="274320">
+              <a:tr h="316992">
                 <a:tc>
                   <a:txBody>
                     <a:bodyPr/>
                     <a:lstStyle/>
                     <a:p>
+                      <a:pPr>
+                        <a:lnSpc>
+                          <a:spcPct val="120000"/>
+                        </a:lnSpc>
+                        <a:spcBef>
+                          <a:spcPts val="300"/>
+                        </a:spcBef>
+                        <a:spcAft>
+                          <a:spcPts val="300"/>
+                        </a:spcAft>
+                        <a:defRPr sz="1000"/>
+                      </a:pPr>
                       <a:r>
                         <a:t>UI base y navegación (sidebar vistas login responsive)</a:t>
                       </a:r>
@@ -4760,7 +5297,18 @@
                     <a:bodyPr/>
                     <a:lstStyle/>
                     <a:p>
-                      <a:pPr algn="r"/>
+                      <a:pPr algn="r">
+                        <a:lnSpc>
+                          <a:spcPct val="120000"/>
+                        </a:lnSpc>
+                        <a:spcBef>
+                          <a:spcPts val="300"/>
+                        </a:spcBef>
+                        <a:spcAft>
+                          <a:spcPts val="300"/>
+                        </a:spcAft>
+                        <a:defRPr sz="1000"/>
+                      </a:pPr>
                       <a:r>
                         <a:t>20</a:t>
                       </a:r>
@@ -4773,7 +5321,18 @@
                     <a:bodyPr/>
                     <a:lstStyle/>
                     <a:p>
-                      <a:pPr algn="r"/>
+                      <a:pPr algn="r">
+                        <a:lnSpc>
+                          <a:spcPct val="120000"/>
+                        </a:lnSpc>
+                        <a:spcBef>
+                          <a:spcPts val="300"/>
+                        </a:spcBef>
+                        <a:spcAft>
+                          <a:spcPts val="300"/>
+                        </a:spcAft>
+                        <a:defRPr sz="1000"/>
+                      </a:pPr>
                       <a:r>
                         <a:t>760</a:t>
                       </a:r>
@@ -4782,12 +5341,24 @@
                   <a:tcPr/>
                 </a:tc>
               </a:tr>
-              <a:tr h="274320">
+              <a:tr h="316992">
                 <a:tc>
                   <a:txBody>
                     <a:bodyPr/>
                     <a:lstStyle/>
                     <a:p>
+                      <a:pPr>
+                        <a:lnSpc>
+                          <a:spcPct val="120000"/>
+                        </a:lnSpc>
+                        <a:spcBef>
+                          <a:spcPts val="300"/>
+                        </a:spcBef>
+                        <a:spcAft>
+                          <a:spcPts val="300"/>
+                        </a:spcAft>
+                        <a:defRPr sz="1000"/>
+                      </a:pPr>
                       <a:r>
                         <a:t>ABM Clientes (listado alta edición permisos)</a:t>
                       </a:r>
@@ -4800,7 +5371,18 @@
                     <a:bodyPr/>
                     <a:lstStyle/>
                     <a:p>
-                      <a:pPr algn="r"/>
+                      <a:pPr algn="r">
+                        <a:lnSpc>
+                          <a:spcPct val="120000"/>
+                        </a:lnSpc>
+                        <a:spcBef>
+                          <a:spcPts val="300"/>
+                        </a:spcBef>
+                        <a:spcAft>
+                          <a:spcPts val="300"/>
+                        </a:spcAft>
+                        <a:defRPr sz="1000"/>
+                      </a:pPr>
                       <a:r>
                         <a:t>8</a:t>
                       </a:r>
@@ -4813,7 +5395,18 @@
                     <a:bodyPr/>
                     <a:lstStyle/>
                     <a:p>
-                      <a:pPr algn="r"/>
+                      <a:pPr algn="r">
+                        <a:lnSpc>
+                          <a:spcPct val="120000"/>
+                        </a:lnSpc>
+                        <a:spcBef>
+                          <a:spcPts val="300"/>
+                        </a:spcBef>
+                        <a:spcAft>
+                          <a:spcPts val="300"/>
+                        </a:spcAft>
+                        <a:defRPr sz="1000"/>
+                      </a:pPr>
                       <a:r>
                         <a:t>304</a:t>
                       </a:r>
@@ -4822,12 +5415,24 @@
                   <a:tcPr/>
                 </a:tc>
               </a:tr>
-              <a:tr h="274320">
+              <a:tr h="316992">
                 <a:tc>
                   <a:txBody>
                     <a:bodyPr/>
                     <a:lstStyle/>
                     <a:p>
+                      <a:pPr>
+                        <a:lnSpc>
+                          <a:spcPct val="120000"/>
+                        </a:lnSpc>
+                        <a:spcBef>
+                          <a:spcPts val="300"/>
+                        </a:spcBef>
+                        <a:spcAft>
+                          <a:spcPts val="300"/>
+                        </a:spcAft>
+                        <a:defRPr sz="1000"/>
+                      </a:pPr>
                       <a:r>
                         <a:t>Módulo Cajas (saldos movimientos tipos Efectivo/Banco)</a:t>
                       </a:r>
@@ -4840,7 +5445,18 @@
                     <a:bodyPr/>
                     <a:lstStyle/>
                     <a:p>
-                      <a:pPr algn="r"/>
+                      <a:pPr algn="r">
+                        <a:lnSpc>
+                          <a:spcPct val="120000"/>
+                        </a:lnSpc>
+                        <a:spcBef>
+                          <a:spcPts val="300"/>
+                        </a:spcBef>
+                        <a:spcAft>
+                          <a:spcPts val="300"/>
+                        </a:spcAft>
+                        <a:defRPr sz="1000"/>
+                      </a:pPr>
                       <a:r>
                         <a:t>24</a:t>
                       </a:r>
@@ -4853,7 +5469,18 @@
                     <a:bodyPr/>
                     <a:lstStyle/>
                     <a:p>
-                      <a:pPr algn="r"/>
+                      <a:pPr algn="r">
+                        <a:lnSpc>
+                          <a:spcPct val="120000"/>
+                        </a:lnSpc>
+                        <a:spcBef>
+                          <a:spcPts val="300"/>
+                        </a:spcBef>
+                        <a:spcAft>
+                          <a:spcPts val="300"/>
+                        </a:spcAft>
+                        <a:defRPr sz="1000"/>
+                      </a:pPr>
                       <a:r>
                         <a:t>912</a:t>
                       </a:r>
@@ -4862,12 +5489,24 @@
                   <a:tcPr/>
                 </a:tc>
               </a:tr>
-              <a:tr h="274320">
+              <a:tr h="316992">
                 <a:tc>
                   <a:txBody>
                     <a:bodyPr/>
                     <a:lstStyle/>
                     <a:p>
+                      <a:pPr>
+                        <a:lnSpc>
+                          <a:spcPct val="120000"/>
+                        </a:lnSpc>
+                        <a:spcBef>
+                          <a:spcPts val="300"/>
+                        </a:spcBef>
+                        <a:spcAft>
+                          <a:spcPts val="300"/>
+                        </a:spcAft>
+                        <a:defRPr sz="1000"/>
+                      </a:pPr>
                       <a:r>
                         <a:t>Módulo Órdenes (CRUD estados concertación monedas)</a:t>
                       </a:r>
@@ -4880,7 +5519,18 @@
                     <a:bodyPr/>
                     <a:lstStyle/>
                     <a:p>
-                      <a:pPr algn="r"/>
+                      <a:pPr algn="r">
+                        <a:lnSpc>
+                          <a:spcPct val="120000"/>
+                        </a:lnSpc>
+                        <a:spcBef>
+                          <a:spcPts val="300"/>
+                        </a:spcBef>
+                        <a:spcAft>
+                          <a:spcPts val="300"/>
+                        </a:spcAft>
+                        <a:defRPr sz="1000"/>
+                      </a:pPr>
                       <a:r>
                         <a:t>32</a:t>
                       </a:r>
@@ -4893,7 +5543,18 @@
                     <a:bodyPr/>
                     <a:lstStyle/>
                     <a:p>
-                      <a:pPr algn="r"/>
+                      <a:pPr algn="r">
+                        <a:lnSpc>
+                          <a:spcPct val="120000"/>
+                        </a:lnSpc>
+                        <a:spcBef>
+                          <a:spcPts val="300"/>
+                        </a:spcBef>
+                        <a:spcAft>
+                          <a:spcPts val="300"/>
+                        </a:spcAft>
+                        <a:defRPr sz="1000"/>
+                      </a:pPr>
                       <a:r>
                         <a:t>1216</a:t>
                       </a:r>
@@ -4902,12 +5563,24 @@
                   <a:tcPr/>
                 </a:tc>
               </a:tr>
-              <a:tr h="274320">
+              <a:tr h="316992">
                 <a:tc>
                   <a:txBody>
                     <a:bodyPr/>
                     <a:lstStyle/>
                     <a:p>
+                      <a:pPr>
+                        <a:lnSpc>
+                          <a:spcPct val="120000"/>
+                        </a:lnSpc>
+                        <a:spcBef>
+                          <a:spcPts val="300"/>
+                        </a:spcBef>
+                        <a:spcAft>
+                          <a:spcPts val="300"/>
+                        </a:spcAft>
+                        <a:defRPr sz="1000"/>
+                      </a:pPr>
                       <a:r>
                         <a:t>Instrumentación y transacciones (intermediarios comisiones)</a:t>
                       </a:r>
@@ -4920,7 +5593,18 @@
                     <a:bodyPr/>
                     <a:lstStyle/>
                     <a:p>
-                      <a:pPr algn="r"/>
+                      <a:pPr algn="r">
+                        <a:lnSpc>
+                          <a:spcPct val="120000"/>
+                        </a:lnSpc>
+                        <a:spcBef>
+                          <a:spcPts val="300"/>
+                        </a:spcBef>
+                        <a:spcAft>
+                          <a:spcPts val="300"/>
+                        </a:spcAft>
+                        <a:defRPr sz="1000"/>
+                      </a:pPr>
                       <a:r>
                         <a:t>28</a:t>
                       </a:r>
@@ -4933,7 +5617,18 @@
                     <a:bodyPr/>
                     <a:lstStyle/>
                     <a:p>
-                      <a:pPr algn="r"/>
+                      <a:pPr algn="r">
+                        <a:lnSpc>
+                          <a:spcPct val="120000"/>
+                        </a:lnSpc>
+                        <a:spcBef>
+                          <a:spcPts val="300"/>
+                        </a:spcBef>
+                        <a:spcAft>
+                          <a:spcPts val="300"/>
+                        </a:spcAft>
+                        <a:defRPr sz="1000"/>
+                      </a:pPr>
                       <a:r>
                         <a:t>1064</a:t>
                       </a:r>
@@ -4942,12 +5637,24 @@
                   <a:tcPr/>
                 </a:tc>
               </a:tr>
-              <a:tr h="274320">
+              <a:tr h="316992">
                 <a:tc>
                   <a:txBody>
                     <a:bodyPr/>
                     <a:lstStyle/>
                     <a:p>
+                      <a:pPr>
+                        <a:lnSpc>
+                          <a:spcPct val="120000"/>
+                        </a:lnSpc>
+                        <a:spcBef>
+                          <a:spcPts val="300"/>
+                        </a:spcBef>
+                        <a:spcAft>
+                          <a:spcPts val="300"/>
+                        </a:spcAft>
+                        <a:defRPr sz="1000"/>
+                      </a:pPr>
                       <a:r>
                         <a:t>Cuenta corriente (cliente e intermediario conciliación)</a:t>
                       </a:r>
@@ -4960,7 +5667,18 @@
                     <a:bodyPr/>
                     <a:lstStyle/>
                     <a:p>
-                      <a:pPr algn="r"/>
+                      <a:pPr algn="r">
+                        <a:lnSpc>
+                          <a:spcPct val="120000"/>
+                        </a:lnSpc>
+                        <a:spcBef>
+                          <a:spcPts val="300"/>
+                        </a:spcBef>
+                        <a:spcAft>
+                          <a:spcPts val="300"/>
+                        </a:spcAft>
+                        <a:defRPr sz="1000"/>
+                      </a:pPr>
                       <a:r>
                         <a:t>24</a:t>
                       </a:r>
@@ -4973,7 +5691,18 @@
                     <a:bodyPr/>
                     <a:lstStyle/>
                     <a:p>
-                      <a:pPr algn="r"/>
+                      <a:pPr algn="r">
+                        <a:lnSpc>
+                          <a:spcPct val="120000"/>
+                        </a:lnSpc>
+                        <a:spcBef>
+                          <a:spcPts val="300"/>
+                        </a:spcBef>
+                        <a:spcAft>
+                          <a:spcPts val="300"/>
+                        </a:spcAft>
+                        <a:defRPr sz="1000"/>
+                      </a:pPr>
                       <a:r>
                         <a:t>912</a:t>
                       </a:r>
@@ -4982,12 +5711,24 @@
                   <a:tcPr/>
                 </a:tc>
               </a:tr>
-              <a:tr h="274320">
+              <a:tr h="316992">
                 <a:tc>
                   <a:txBody>
                     <a:bodyPr/>
                     <a:lstStyle/>
                     <a:p>
+                      <a:pPr>
+                        <a:lnSpc>
+                          <a:spcPct val="120000"/>
+                        </a:lnSpc>
+                        <a:spcBef>
+                          <a:spcPts val="300"/>
+                        </a:spcBef>
+                        <a:spcAft>
+                          <a:spcPts val="300"/>
+                        </a:spcAft>
+                        <a:defRPr sz="1000"/>
+                      </a:pPr>
                       <a:r>
                         <a:t>Panel de Control (saldos pendientes accesos parametrizable)</a:t>
                       </a:r>
@@ -5000,7 +5741,18 @@
                     <a:bodyPr/>
                     <a:lstStyle/>
                     <a:p>
-                      <a:pPr algn="r"/>
+                      <a:pPr algn="r">
+                        <a:lnSpc>
+                          <a:spcPct val="120000"/>
+                        </a:lnSpc>
+                        <a:spcBef>
+                          <a:spcPts val="300"/>
+                        </a:spcBef>
+                        <a:spcAft>
+                          <a:spcPts val="300"/>
+                        </a:spcAft>
+                        <a:defRPr sz="1000"/>
+                      </a:pPr>
                       <a:r>
                         <a:t>16</a:t>
                       </a:r>
@@ -5013,7 +5765,18 @@
                     <a:bodyPr/>
                     <a:lstStyle/>
                     <a:p>
-                      <a:pPr algn="r"/>
+                      <a:pPr algn="r">
+                        <a:lnSpc>
+                          <a:spcPct val="120000"/>
+                        </a:lnSpc>
+                        <a:spcBef>
+                          <a:spcPts val="300"/>
+                        </a:spcBef>
+                        <a:spcAft>
+                          <a:spcPts val="300"/>
+                        </a:spcAft>
+                        <a:defRPr sz="1000"/>
+                      </a:pPr>
                       <a:r>
                         <a:t>608</a:t>
                       </a:r>
@@ -5022,12 +5785,24 @@
                   <a:tcPr/>
                 </a:tc>
               </a:tr>
-              <a:tr h="274320">
+              <a:tr h="316992">
                 <a:tc>
                   <a:txBody>
                     <a:bodyPr/>
                     <a:lstStyle/>
                     <a:p>
+                      <a:pPr>
+                        <a:lnSpc>
+                          <a:spcPct val="120000"/>
+                        </a:lnSpc>
+                        <a:spcBef>
+                          <a:spcPts val="300"/>
+                        </a:spcBef>
+                        <a:spcAft>
+                          <a:spcPts val="300"/>
+                        </a:spcAft>
+                        <a:defRPr sz="1000"/>
+                      </a:pPr>
                       <a:r>
                         <a:t>Permisos granulares y control de vistas por rol</a:t>
                       </a:r>
@@ -5040,7 +5815,18 @@
                     <a:bodyPr/>
                     <a:lstStyle/>
                     <a:p>
-                      <a:pPr algn="r"/>
+                      <a:pPr algn="r">
+                        <a:lnSpc>
+                          <a:spcPct val="120000"/>
+                        </a:lnSpc>
+                        <a:spcBef>
+                          <a:spcPts val="300"/>
+                        </a:spcBef>
+                        <a:spcAft>
+                          <a:spcPts val="300"/>
+                        </a:spcAft>
+                        <a:defRPr sz="1000"/>
+                      </a:pPr>
                       <a:r>
                         <a:t>12</a:t>
                       </a:r>
@@ -5053,7 +5839,18 @@
                     <a:bodyPr/>
                     <a:lstStyle/>
                     <a:p>
-                      <a:pPr algn="r"/>
+                      <a:pPr algn="r">
+                        <a:lnSpc>
+                          <a:spcPct val="120000"/>
+                        </a:lnSpc>
+                        <a:spcBef>
+                          <a:spcPts val="300"/>
+                        </a:spcBef>
+                        <a:spcAft>
+                          <a:spcPts val="300"/>
+                        </a:spcAft>
+                        <a:defRPr sz="1000"/>
+                      </a:pPr>
                       <a:r>
                         <a:t>456</a:t>
                       </a:r>
@@ -5062,12 +5859,24 @@
                   <a:tcPr/>
                 </a:tc>
               </a:tr>
-              <a:tr h="274320">
+              <a:tr h="316992">
                 <a:tc>
                   <a:txBody>
                     <a:bodyPr/>
                     <a:lstStyle/>
                     <a:p>
+                      <a:pPr>
+                        <a:lnSpc>
+                          <a:spcPct val="120000"/>
+                        </a:lnSpc>
+                        <a:spcBef>
+                          <a:spcPts val="300"/>
+                        </a:spcBef>
+                        <a:spcAft>
+                          <a:spcPts val="300"/>
+                        </a:spcAft>
+                        <a:defRPr sz="1000"/>
+                      </a:pPr>
                       <a:r>
                         <a:t>Experiencia de usuario (toast confirm validaciones)</a:t>
                       </a:r>
@@ -5080,7 +5889,18 @@
                     <a:bodyPr/>
                     <a:lstStyle/>
                     <a:p>
-                      <a:pPr algn="r"/>
+                      <a:pPr algn="r">
+                        <a:lnSpc>
+                          <a:spcPct val="120000"/>
+                        </a:lnSpc>
+                        <a:spcBef>
+                          <a:spcPts val="300"/>
+                        </a:spcBef>
+                        <a:spcAft>
+                          <a:spcPts val="300"/>
+                        </a:spcAft>
+                        <a:defRPr sz="1000"/>
+                      </a:pPr>
                       <a:r>
                         <a:t>8</a:t>
                       </a:r>
@@ -5093,7 +5913,18 @@
                     <a:bodyPr/>
                     <a:lstStyle/>
                     <a:p>
-                      <a:pPr algn="r"/>
+                      <a:pPr algn="r">
+                        <a:lnSpc>
+                          <a:spcPct val="120000"/>
+                        </a:lnSpc>
+                        <a:spcBef>
+                          <a:spcPts val="300"/>
+                        </a:spcBef>
+                        <a:spcAft>
+                          <a:spcPts val="300"/>
+                        </a:spcAft>
+                        <a:defRPr sz="1000"/>
+                      </a:pPr>
                       <a:r>
                         <a:t>304</a:t>
                       </a:r>
@@ -5102,12 +5933,24 @@
                   <a:tcPr/>
                 </a:tc>
               </a:tr>
-              <a:tr h="274320">
+              <a:tr h="316992">
                 <a:tc>
                   <a:txBody>
                     <a:bodyPr/>
                     <a:lstStyle/>
                     <a:p>
+                      <a:pPr>
+                        <a:lnSpc>
+                          <a:spcPct val="120000"/>
+                        </a:lnSpc>
+                        <a:spcBef>
+                          <a:spcPts val="300"/>
+                        </a:spcBef>
+                        <a:spcAft>
+                          <a:spcPts val="300"/>
+                        </a:spcAft>
+                        <a:defRPr sz="1000"/>
+                      </a:pPr>
                       <a:r>
                         <a:t>Responsive y adaptación móvil (touch safe area)</a:t>
                       </a:r>
@@ -5120,7 +5963,18 @@
                     <a:bodyPr/>
                     <a:lstStyle/>
                     <a:p>
-                      <a:pPr algn="r"/>
+                      <a:pPr algn="r">
+                        <a:lnSpc>
+                          <a:spcPct val="120000"/>
+                        </a:lnSpc>
+                        <a:spcBef>
+                          <a:spcPts val="300"/>
+                        </a:spcBef>
+                        <a:spcAft>
+                          <a:spcPts val="300"/>
+                        </a:spcAft>
+                        <a:defRPr sz="1000"/>
+                      </a:pPr>
                       <a:r>
                         <a:t>12</a:t>
                       </a:r>
@@ -5133,7 +5987,18 @@
                     <a:bodyPr/>
                     <a:lstStyle/>
                     <a:p>
-                      <a:pPr algn="r"/>
+                      <a:pPr algn="r">
+                        <a:lnSpc>
+                          <a:spcPct val="120000"/>
+                        </a:lnSpc>
+                        <a:spcBef>
+                          <a:spcPts val="300"/>
+                        </a:spcBef>
+                        <a:spcAft>
+                          <a:spcPts val="300"/>
+                        </a:spcAft>
+                        <a:defRPr sz="1000"/>
+                      </a:pPr>
                       <a:r>
                         <a:t>456</a:t>
                       </a:r>
@@ -5142,12 +6007,24 @@
                   <a:tcPr/>
                 </a:tc>
               </a:tr>
-              <a:tr h="274320">
+              <a:tr h="316992">
                 <a:tc>
                   <a:txBody>
                     <a:bodyPr/>
                     <a:lstStyle/>
                     <a:p>
+                      <a:pPr>
+                        <a:lnSpc>
+                          <a:spcPct val="120000"/>
+                        </a:lnSpc>
+                        <a:spcBef>
+                          <a:spcPts val="300"/>
+                        </a:spcBef>
+                        <a:spcAft>
+                          <a:spcPts val="300"/>
+                        </a:spcAft>
+                        <a:defRPr sz="1000"/>
+                      </a:pPr>
                       <a:r>
                         <a:t>Documentación bitácora y despliegue continuo</a:t>
                       </a:r>
@@ -5160,7 +6037,18 @@
                     <a:bodyPr/>
                     <a:lstStyle/>
                     <a:p>
-                      <a:pPr algn="r"/>
+                      <a:pPr algn="r">
+                        <a:lnSpc>
+                          <a:spcPct val="120000"/>
+                        </a:lnSpc>
+                        <a:spcBef>
+                          <a:spcPts val="300"/>
+                        </a:spcBef>
+                        <a:spcAft>
+                          <a:spcPts val="300"/>
+                        </a:spcAft>
+                        <a:defRPr sz="1000"/>
+                      </a:pPr>
                       <a:r>
                         <a:t>12</a:t>
                       </a:r>
@@ -5173,7 +6061,18 @@
                     <a:bodyPr/>
                     <a:lstStyle/>
                     <a:p>
-                      <a:pPr algn="r"/>
+                      <a:pPr algn="r">
+                        <a:lnSpc>
+                          <a:spcPct val="120000"/>
+                        </a:lnSpc>
+                        <a:spcBef>
+                          <a:spcPts val="300"/>
+                        </a:spcBef>
+                        <a:spcAft>
+                          <a:spcPts val="300"/>
+                        </a:spcAft>
+                        <a:defRPr sz="1000"/>
+                      </a:pPr>
                       <a:r>
                         <a:t>456</a:t>
                       </a:r>
@@ -5182,14 +6081,23 @@
                   <a:tcPr/>
                 </a:tc>
               </a:tr>
-              <a:tr h="274320">
+              <a:tr h="316992">
                 <a:tc>
                   <a:txBody>
                     <a:bodyPr/>
                     <a:lstStyle/>
                     <a:p>
                       <a:pPr>
-                        <a:defRPr b="1"/>
+                        <a:lnSpc>
+                          <a:spcPct val="120000"/>
+                        </a:lnSpc>
+                        <a:spcBef>
+                          <a:spcPts val="300"/>
+                        </a:spcBef>
+                        <a:spcAft>
+                          <a:spcPts val="300"/>
+                        </a:spcAft>
+                        <a:defRPr sz="1000" b="1"/>
                       </a:pPr>
                       <a:r>
                         <a:t>TOTAL</a:t>
@@ -5208,7 +6116,16 @@
                     <a:lstStyle/>
                     <a:p>
                       <a:pPr algn="r">
-                        <a:defRPr b="1"/>
+                        <a:lnSpc>
+                          <a:spcPct val="120000"/>
+                        </a:lnSpc>
+                        <a:spcBef>
+                          <a:spcPts val="300"/>
+                        </a:spcBef>
+                        <a:spcAft>
+                          <a:spcPts val="300"/>
+                        </a:spcAft>
+                        <a:defRPr sz="1000" b="1"/>
                       </a:pPr>
                       <a:r>
                         <a:t>232</a:t>
@@ -5227,7 +6144,16 @@
                     <a:lstStyle/>
                     <a:p>
                       <a:pPr algn="r">
-                        <a:defRPr b="1"/>
+                        <a:lnSpc>
+                          <a:spcPct val="120000"/>
+                        </a:lnSpc>
+                        <a:spcBef>
+                          <a:spcPts val="300"/>
+                        </a:spcBef>
+                        <a:spcAft>
+                          <a:spcPts val="300"/>
+                        </a:spcAft>
+                        <a:defRPr sz="1000" b="1"/>
                       </a:pPr>
                       <a:r>
                         <a:t>8816</a:t>
@@ -5245,6 +6171,41 @@
           </a:graphicData>
         </a:graphic>
       </p:graphicFrame>
+      <p:sp>
+        <p:nvSpPr>
+          <p:cNvPr id="7" name="TextBox 6"/>
+          <p:cNvSpPr txBox="1"/>
+          <p:nvPr/>
+        </p:nvSpPr>
+        <p:spPr>
+          <a:xfrm>
+            <a:off x="10972800" y="6446520"/>
+            <a:ext cx="1097280" cy="320040"/>
+          </a:xfrm>
+          <a:prstGeom prst="rect">
+            <a:avLst/>
+          </a:prstGeom>
+          <a:noFill/>
+        </p:spPr>
+        <p:txBody>
+          <a:bodyPr wrap="none">
+            <a:spAutoFit/>
+          </a:bodyPr>
+          <a:lstStyle/>
+          <a:p>
+            <a:pPr algn="r">
+              <a:defRPr sz="1000">
+                <a:solidFill>
+                  <a:srgbClr val="555555"/>
+                </a:solidFill>
+              </a:defRPr>
+            </a:pPr>
+            <a:r>
+              <a:t>6 / 8</a:t>
+            </a:r>
+          </a:p>
+        </p:txBody>
+      </p:sp>
     </p:spTree>
   </p:cSld>
   <p:clrMapOvr>
@@ -5278,7 +6239,7 @@
             <a:avLst/>
           </a:prstGeom>
           <a:solidFill>
-            <a:srgbClr val="0D7D3D"/>
+            <a:srgbClr val="0D2137"/>
           </a:solidFill>
           <a:ln>
             <a:noFill/>
@@ -5373,7 +6334,7 @@
         </p:nvSpPr>
         <p:spPr>
           <a:xfrm>
-            <a:off x="457200" y="868680"/>
+            <a:off x="457200" y="914400"/>
             <a:ext cx="11247120" cy="5486400"/>
           </a:xfrm>
           <a:prstGeom prst="rect">
@@ -5388,9 +6349,15 @@
           <a:lstStyle/>
           <a:p>
             <a:pPr>
+              <a:lnSpc>
+                <a:spcPct val="120000"/>
+              </a:lnSpc>
               <a:spcBef>
-                <a:spcPts val="600"/>
+                <a:spcPts val="800"/>
               </a:spcBef>
+              <a:spcAft>
+                <a:spcPts val="200"/>
+              </a:spcAft>
               <a:defRPr sz="1400">
                 <a:solidFill>
                   <a:srgbClr val="1A1A1A"/>
@@ -5403,9 +6370,15 @@
           </a:p>
           <a:p>
             <a:pPr>
+              <a:lnSpc>
+                <a:spcPct val="120000"/>
+              </a:lnSpc>
               <a:spcBef>
-                <a:spcPts val="600"/>
+                <a:spcPts val="800"/>
               </a:spcBef>
+              <a:spcAft>
+                <a:spcPts val="200"/>
+              </a:spcAft>
               <a:defRPr sz="1400">
                 <a:solidFill>
                   <a:srgbClr val="1A1A1A"/>
@@ -5418,9 +6391,15 @@
           </a:p>
           <a:p>
             <a:pPr>
+              <a:lnSpc>
+                <a:spcPct val="120000"/>
+              </a:lnSpc>
               <a:spcBef>
-                <a:spcPts val="600"/>
+                <a:spcPts val="800"/>
               </a:spcBef>
+              <a:spcAft>
+                <a:spcPts val="200"/>
+              </a:spcAft>
               <a:defRPr sz="1400">
                 <a:solidFill>
                   <a:srgbClr val="1A1A1A"/>
@@ -5433,9 +6412,15 @@
           </a:p>
           <a:p>
             <a:pPr>
+              <a:lnSpc>
+                <a:spcPct val="120000"/>
+              </a:lnSpc>
               <a:spcBef>
-                <a:spcPts val="600"/>
+                <a:spcPts val="800"/>
               </a:spcBef>
+              <a:spcAft>
+                <a:spcPts val="200"/>
+              </a:spcAft>
               <a:defRPr sz="1400">
                 <a:solidFill>
                   <a:srgbClr val="1A1A1A"/>
@@ -5448,9 +6433,15 @@
           </a:p>
           <a:p>
             <a:pPr>
+              <a:lnSpc>
+                <a:spcPct val="120000"/>
+              </a:lnSpc>
               <a:spcBef>
-                <a:spcPts val="600"/>
+                <a:spcPts val="800"/>
               </a:spcBef>
+              <a:spcAft>
+                <a:spcPts val="200"/>
+              </a:spcAft>
               <a:defRPr sz="1400">
                 <a:solidFill>
                   <a:srgbClr val="1A1A1A"/>
@@ -5471,8 +6462,8 @@
         </p:nvSpPr>
         <p:spPr>
           <a:xfrm>
-            <a:off x="457200" y="5943600"/>
-            <a:ext cx="11247120" cy="548640"/>
+            <a:off x="457200" y="5852160"/>
+            <a:ext cx="11247120" cy="640080"/>
           </a:xfrm>
           <a:prstGeom prst="rect">
             <a:avLst/>
@@ -5486,6 +6477,9 @@
           <a:lstStyle/>
           <a:p>
             <a:pPr>
+              <a:lnSpc>
+                <a:spcPct val="120000"/>
+              </a:lnSpc>
               <a:defRPr sz="1200" i="1">
                 <a:solidFill>
                   <a:srgbClr val="555555"/>
@@ -5494,6 +6488,41 @@
             </a:pPr>
             <a:r>
               <a:t>Gracias por considerar esta propuesta. Quedamos a disposición para ajustar alcance o plazos.</a:t>
+            </a:r>
+          </a:p>
+        </p:txBody>
+      </p:sp>
+      <p:sp>
+        <p:nvSpPr>
+          <p:cNvPr id="7" name="TextBox 6"/>
+          <p:cNvSpPr txBox="1"/>
+          <p:nvPr/>
+        </p:nvSpPr>
+        <p:spPr>
+          <a:xfrm>
+            <a:off x="10972800" y="6446520"/>
+            <a:ext cx="1097280" cy="320040"/>
+          </a:xfrm>
+          <a:prstGeom prst="rect">
+            <a:avLst/>
+          </a:prstGeom>
+          <a:noFill/>
+        </p:spPr>
+        <p:txBody>
+          <a:bodyPr wrap="none">
+            <a:spAutoFit/>
+          </a:bodyPr>
+          <a:lstStyle/>
+          <a:p>
+            <a:pPr algn="r">
+              <a:defRPr sz="1000">
+                <a:solidFill>
+                  <a:srgbClr val="555555"/>
+                </a:solidFill>
+              </a:defRPr>
+            </a:pPr>
+            <a:r>
+              <a:t>7 / 8</a:t>
             </a:r>
           </a:p>
         </p:txBody>
@@ -5531,7 +6560,7 @@
             <a:avLst/>
           </a:prstGeom>
           <a:solidFill>
-            <a:srgbClr val="0D7D3D"/>
+            <a:srgbClr val="0D2137"/>
           </a:solidFill>
           <a:ln>
             <a:noFill/>
@@ -5626,8 +6655,8 @@
         </p:nvSpPr>
         <p:spPr>
           <a:xfrm>
-            <a:off x="457200" y="3200400"/>
-            <a:ext cx="11247120" cy="457200"/>
+            <a:off x="457200" y="3108960"/>
+            <a:ext cx="11247120" cy="640080"/>
           </a:xfrm>
           <a:prstGeom prst="rect">
             <a:avLst/>
@@ -5641,6 +6670,9 @@
           <a:lstStyle/>
           <a:p>
             <a:pPr algn="ctr">
+              <a:lnSpc>
+                <a:spcPct val="120000"/>
+              </a:lnSpc>
               <a:defRPr sz="1400">
                 <a:solidFill>
                   <a:srgbClr val="555555"/>
@@ -5649,6 +6681,41 @@
             </a:pPr>
             <a:r>
               <a:t>Quedamos a disposición para ajustar alcance o plazos.</a:t>
+            </a:r>
+          </a:p>
+        </p:txBody>
+      </p:sp>
+      <p:sp>
+        <p:nvSpPr>
+          <p:cNvPr id="6" name="TextBox 5"/>
+          <p:cNvSpPr txBox="1"/>
+          <p:nvPr/>
+        </p:nvSpPr>
+        <p:spPr>
+          <a:xfrm>
+            <a:off x="10972800" y="6446520"/>
+            <a:ext cx="1097280" cy="320040"/>
+          </a:xfrm>
+          <a:prstGeom prst="rect">
+            <a:avLst/>
+          </a:prstGeom>
+          <a:noFill/>
+        </p:spPr>
+        <p:txBody>
+          <a:bodyPr wrap="none">
+            <a:spAutoFit/>
+          </a:bodyPr>
+          <a:lstStyle/>
+          <a:p>
+            <a:pPr algn="r">
+              <a:defRPr sz="1000">
+                <a:solidFill>
+                  <a:srgbClr val="555555"/>
+                </a:solidFill>
+              </a:defRPr>
+            </a:pPr>
+            <a:r>
+              <a:t>8 / 8</a:t>
             </a:r>
           </a:p>
         </p:txBody>

</xml_diff>